<commit_message>
actualizacion de presentacion inicial
</commit_message>
<xml_diff>
--- a/Equip_29/Results/2026_06_01_StaySpain_Presentacion.pptx
+++ b/Equip_29/Results/2026_06_01_StaySpain_Presentacion.pptx
@@ -1675,7 +1675,7 @@
                 <a:ea typeface="Calibri" pitchFamily="34" charset="-122"/>
                 <a:cs typeface="Calibri" pitchFamily="34" charset="-120"/>
               </a:rPr>
-              <a:t>DESAFÍO Nº 2 · DEPARTAMENTO DE ANALISTAS DE DATOS</a:t>
+              <a:t>DEPARTAMENTO DE ANALISTAS DE DATOS</a:t>
             </a:r>
             <a:endParaRPr lang="en-US" sz="1100" dirty="0"/>
           </a:p>
@@ -1948,7 +1948,7 @@
                 <a:ea typeface="Calibri" pitchFamily="34" charset="-122"/>
                 <a:cs typeface="Calibri" pitchFamily="34" charset="-120"/>
               </a:rPr>
-              <a:t>Equipo 29  ·  Junio 2026</a:t>
+              <a:t>Junio 2026</a:t>
             </a:r>
             <a:endParaRPr lang="en-US" sz="1100" dirty="0"/>
           </a:p>
@@ -2647,207 +2647,13 @@
       </p:sp>
       <p:sp>
         <p:nvSpPr>
-          <p:cNvPr id="4" name="Text 2"/>
-          <p:cNvSpPr/>
-          <p:nvPr/>
-        </p:nvSpPr>
-        <p:spPr>
-          <a:xfrm>
-            <a:off x="457200" y="1508760"/>
-            <a:ext cx="3931920" cy="365760"/>
-          </a:xfrm>
-          <a:prstGeom prst="rect">
-            <a:avLst/>
-          </a:prstGeom>
-          <a:noFill/>
-          <a:ln/>
-        </p:spPr>
-        <p:txBody>
-          <a:bodyPr wrap="square" lIns="0" tIns="0" rIns="0" bIns="0" rtlCol="0" anchor="ctr"/>
-          <a:lstStyle/>
-          <a:p>
-            <a:pPr marL="0" indent="0">
-              <a:buNone/>
-            </a:pPr>
-            <a:r>
-              <a:rPr lang="en-US" sz="1600" b="1" dirty="0">
-                <a:solidFill>
-                  <a:srgbClr val="1E3A5F"/>
-                </a:solidFill>
-                <a:latin typeface="Calibri" pitchFamily="34" charset="0"/>
-                <a:ea typeface="Calibri" pitchFamily="34" charset="-122"/>
-                <a:cs typeface="Calibri" pitchFamily="34" charset="-120"/>
-              </a:rPr>
-              <a:t>Contexto del negocio</a:t>
-            </a:r>
-            <a:endParaRPr lang="en-US" sz="1600" dirty="0"/>
-          </a:p>
-        </p:txBody>
-      </p:sp>
-      <p:sp>
-        <p:nvSpPr>
-          <p:cNvPr id="5" name="Text 3"/>
-          <p:cNvSpPr/>
-          <p:nvPr/>
-        </p:nvSpPr>
-        <p:spPr>
-          <a:xfrm>
-            <a:off x="457200" y="1920240"/>
-            <a:ext cx="3931920" cy="2743200"/>
-          </a:xfrm>
-          <a:prstGeom prst="rect">
-            <a:avLst/>
-          </a:prstGeom>
-          <a:noFill/>
-          <a:ln/>
-        </p:spPr>
-        <p:txBody>
-          <a:bodyPr wrap="square" rtlCol="0" anchor="ctr"/>
-          <a:lstStyle/>
-          <a:p>
-            <a:pPr marL="0" indent="0">
-              <a:spcAft>
-                <a:spcPts val="400"/>
-              </a:spcAft>
-              <a:buNone/>
-            </a:pPr>
-            <a:r>
-              <a:rPr lang="en-US" sz="1200" b="1" dirty="0">
-                <a:solidFill>
-                  <a:srgbClr val="1E3A5F"/>
-                </a:solidFill>
-                <a:latin typeface="Calibri" pitchFamily="34" charset="0"/>
-                <a:ea typeface="Calibri" pitchFamily="34" charset="-122"/>
-                <a:cs typeface="Calibri" pitchFamily="34" charset="-120"/>
-              </a:rPr>
-              <a:t>StaySpain</a:t>
-            </a:r>
-            <a:r>
-              <a:rPr lang="en-US" sz="1200" dirty="0">
-                <a:solidFill>
-                  <a:srgbClr val="1E293B"/>
-                </a:solidFill>
-                <a:latin typeface="Calibri" pitchFamily="34" charset="0"/>
-                <a:ea typeface="Calibri" pitchFamily="34" charset="-122"/>
-                <a:cs typeface="Calibri" pitchFamily="34" charset="-120"/>
-              </a:rPr>
-              <a:t> es una plataforma digital que conecta anfitriones y huéspedes en toda España.</a:t>
-            </a:r>
-            <a:endParaRPr lang="en-US" sz="1200" dirty="0"/>
-          </a:p>
-          <a:p>
-            <a:pPr marL="0" indent="0">
-              <a:spcAft>
-                <a:spcPts val="400"/>
-              </a:spcAft>
-              <a:buNone/>
-            </a:pPr>
-            <a:endParaRPr lang="en-US" sz="1200" dirty="0"/>
-          </a:p>
-          <a:p>
-            <a:pPr marL="0" indent="0">
-              <a:spcAft>
-                <a:spcPts val="400"/>
-              </a:spcAft>
-              <a:buNone/>
-            </a:pPr>
-            <a:r>
-              <a:rPr lang="en-US" sz="1200" dirty="0">
-                <a:solidFill>
-                  <a:srgbClr val="1E293B"/>
-                </a:solidFill>
-                <a:latin typeface="Calibri" pitchFamily="34" charset="0"/>
-                <a:ea typeface="Calibri" pitchFamily="34" charset="-122"/>
-                <a:cs typeface="Calibri" pitchFamily="34" charset="-120"/>
-              </a:rPr>
-              <a:t>Como Departamento de Analistas de Datos, nuestro trabajo es transformar la información de los anuncios en </a:t>
-            </a:r>
-            <a:r>
-              <a:rPr lang="en-US" sz="1200" b="1" dirty="0">
-                <a:solidFill>
-                  <a:srgbClr val="1E293B"/>
-                </a:solidFill>
-                <a:latin typeface="Calibri" pitchFamily="34" charset="0"/>
-                <a:ea typeface="Calibri" pitchFamily="34" charset="-122"/>
-                <a:cs typeface="Calibri" pitchFamily="34" charset="-120"/>
-              </a:rPr>
-              <a:t>conocimiento estratégico</a:t>
-            </a:r>
-            <a:r>
-              <a:rPr lang="en-US" sz="1200" dirty="0">
-                <a:solidFill>
-                  <a:srgbClr val="1E293B"/>
-                </a:solidFill>
-                <a:latin typeface="Calibri" pitchFamily="34" charset="0"/>
-                <a:ea typeface="Calibri" pitchFamily="34" charset="-122"/>
-                <a:cs typeface="Calibri" pitchFamily="34" charset="-120"/>
-              </a:rPr>
-              <a:t> para la dirección.</a:t>
-            </a:r>
-            <a:endParaRPr lang="en-US" sz="1200" dirty="0"/>
-          </a:p>
-          <a:p>
-            <a:pPr marL="0" indent="0">
-              <a:spcAft>
-                <a:spcPts val="400"/>
-              </a:spcAft>
-              <a:buNone/>
-            </a:pPr>
-            <a:endParaRPr lang="en-US" sz="1200" dirty="0"/>
-          </a:p>
-          <a:p>
-            <a:pPr marL="0" indent="0">
-              <a:spcAft>
-                <a:spcPts val="400"/>
-              </a:spcAft>
-              <a:buNone/>
-            </a:pPr>
-            <a:r>
-              <a:rPr lang="en-US" sz="1200" dirty="0">
-                <a:solidFill>
-                  <a:srgbClr val="1E293B"/>
-                </a:solidFill>
-                <a:latin typeface="Calibri" pitchFamily="34" charset="0"/>
-                <a:ea typeface="Calibri" pitchFamily="34" charset="-122"/>
-                <a:cs typeface="Calibri" pitchFamily="34" charset="-120"/>
-              </a:rPr>
-              <a:t>El dataset es una </a:t>
-            </a:r>
-            <a:r>
-              <a:rPr lang="en-US" sz="1200" i="1" dirty="0">
-                <a:solidFill>
-                  <a:srgbClr val="1E293B"/>
-                </a:solidFill>
-                <a:latin typeface="Calibri" pitchFamily="34" charset="0"/>
-                <a:ea typeface="Calibri" pitchFamily="34" charset="-122"/>
-                <a:cs typeface="Calibri" pitchFamily="34" charset="-120"/>
-              </a:rPr>
-              <a:t>fotografía</a:t>
-            </a:r>
-            <a:r>
-              <a:rPr lang="en-US" sz="1200" dirty="0">
-                <a:solidFill>
-                  <a:srgbClr val="1E293B"/>
-                </a:solidFill>
-                <a:latin typeface="Calibri" pitchFamily="34" charset="0"/>
-                <a:ea typeface="Calibri" pitchFamily="34" charset="-122"/>
-                <a:cs typeface="Calibri" pitchFamily="34" charset="-120"/>
-              </a:rPr>
-              <a:t> de los anuncios publicados — no una serie temporal — con información de ubicación, capacidad, calendario y valoraciones.</a:t>
-            </a:r>
-            <a:endParaRPr lang="en-US" sz="1200" dirty="0"/>
-          </a:p>
-        </p:txBody>
-      </p:sp>
-      <p:sp>
-        <p:nvSpPr>
           <p:cNvPr id="6" name="Shape 4"/>
           <p:cNvSpPr/>
           <p:nvPr/>
         </p:nvSpPr>
         <p:spPr>
           <a:xfrm>
-            <a:off x="4846320" y="1415996"/>
+            <a:off x="4484370" y="1324556"/>
             <a:ext cx="3840480" cy="1051560"/>
           </a:xfrm>
           <a:prstGeom prst="roundRect">
@@ -2881,7 +2687,7 @@
         </p:nvSpPr>
         <p:spPr>
           <a:xfrm>
-            <a:off x="5074920" y="1507436"/>
+            <a:off x="4712970" y="1415996"/>
             <a:ext cx="3383280" cy="228600"/>
           </a:xfrm>
           <a:prstGeom prst="rect">
@@ -2920,7 +2726,7 @@
         </p:nvSpPr>
         <p:spPr>
           <a:xfrm>
-            <a:off x="5074920" y="1745180"/>
+            <a:off x="4712970" y="1653740"/>
             <a:ext cx="3383280" cy="329184"/>
           </a:xfrm>
           <a:prstGeom prst="rect">
@@ -2959,7 +2765,7 @@
         </p:nvSpPr>
         <p:spPr>
           <a:xfrm>
-            <a:off x="5074920" y="2092652"/>
+            <a:off x="4712970" y="2001212"/>
             <a:ext cx="3383280" cy="347472"/>
           </a:xfrm>
           <a:prstGeom prst="rect">
@@ -2998,7 +2804,7 @@
         </p:nvSpPr>
         <p:spPr>
           <a:xfrm>
-            <a:off x="4846320" y="2558996"/>
+            <a:off x="4484370" y="2467556"/>
             <a:ext cx="3840480" cy="1051560"/>
           </a:xfrm>
           <a:prstGeom prst="roundRect">
@@ -3032,7 +2838,7 @@
         </p:nvSpPr>
         <p:spPr>
           <a:xfrm>
-            <a:off x="5074920" y="2650436"/>
+            <a:off x="4712970" y="2558996"/>
             <a:ext cx="3383280" cy="228600"/>
           </a:xfrm>
           <a:prstGeom prst="rect">
@@ -3071,7 +2877,7 @@
         </p:nvSpPr>
         <p:spPr>
           <a:xfrm>
-            <a:off x="5074920" y="2888180"/>
+            <a:off x="4712970" y="2796740"/>
             <a:ext cx="3383280" cy="329184"/>
           </a:xfrm>
           <a:prstGeom prst="rect">
@@ -3110,7 +2916,7 @@
         </p:nvSpPr>
         <p:spPr>
           <a:xfrm>
-            <a:off x="5074920" y="3235652"/>
+            <a:off x="4712970" y="3144212"/>
             <a:ext cx="3383280" cy="347472"/>
           </a:xfrm>
           <a:prstGeom prst="rect">
@@ -3149,7 +2955,7 @@
         </p:nvSpPr>
         <p:spPr>
           <a:xfrm>
-            <a:off x="4846320" y="3701996"/>
+            <a:off x="4484370" y="3610556"/>
             <a:ext cx="3840480" cy="1051560"/>
           </a:xfrm>
           <a:prstGeom prst="roundRect">
@@ -3183,7 +2989,7 @@
         </p:nvSpPr>
         <p:spPr>
           <a:xfrm>
-            <a:off x="5074920" y="3793436"/>
+            <a:off x="4712970" y="3701996"/>
             <a:ext cx="3383280" cy="228600"/>
           </a:xfrm>
           <a:prstGeom prst="rect">
@@ -3222,7 +3028,7 @@
         </p:nvSpPr>
         <p:spPr>
           <a:xfrm>
-            <a:off x="5074920" y="4031180"/>
+            <a:off x="4712970" y="3939740"/>
             <a:ext cx="3383280" cy="329184"/>
           </a:xfrm>
           <a:prstGeom prst="rect">
@@ -3261,7 +3067,7 @@
         </p:nvSpPr>
         <p:spPr>
           <a:xfrm>
-            <a:off x="5074920" y="4378652"/>
+            <a:off x="4712970" y="4287212"/>
             <a:ext cx="3383280" cy="347472"/>
           </a:xfrm>
           <a:prstGeom prst="rect">
@@ -3348,6 +3154,36 @@
           </a:p>
         </p:txBody>
       </p:sp>
+      <p:pic>
+        <p:nvPicPr>
+          <p:cNvPr id="20" name="Imagen 19">
+            <a:extLst>
+              <a:ext uri="{FF2B5EF4-FFF2-40B4-BE49-F238E27FC236}">
+                <a16:creationId xmlns:a16="http://schemas.microsoft.com/office/drawing/2014/main" id="{F7879402-34C4-2EEA-651A-4585A5071D6F}"/>
+              </a:ext>
+            </a:extLst>
+          </p:cNvPr>
+          <p:cNvPicPr>
+            <a:picLocks noChangeAspect="1"/>
+          </p:cNvPicPr>
+          <p:nvPr/>
+        </p:nvPicPr>
+        <p:blipFill>
+          <a:blip r:embed="rId3"/>
+          <a:stretch>
+            <a:fillRect/>
+          </a:stretch>
+        </p:blipFill>
+        <p:spPr>
+          <a:xfrm>
+            <a:off x="457200" y="1125890"/>
+            <a:ext cx="3195337" cy="3628990"/>
+          </a:xfrm>
+          <a:prstGeom prst="rect">
+            <a:avLst/>
+          </a:prstGeom>
+        </p:spPr>
+      </p:pic>
     </p:spTree>
   </p:cSld>
   <p:clrMapOvr>
@@ -3470,10 +3306,10 @@
       </p:sp>
       <p:pic>
         <p:nvPicPr>
-          <p:cNvPr id="4" name="Imagen 3">
+          <p:cNvPr id="5" name="Imagen 4">
             <a:extLst>
               <a:ext uri="{FF2B5EF4-FFF2-40B4-BE49-F238E27FC236}">
-                <a16:creationId xmlns:a16="http://schemas.microsoft.com/office/drawing/2014/main" id="{DBEEA8D0-816F-C072-892D-85975CF350E2}"/>
+                <a16:creationId xmlns:a16="http://schemas.microsoft.com/office/drawing/2014/main" id="{70752296-0699-9D64-A4FF-787B5C4DE559}"/>
               </a:ext>
             </a:extLst>
           </p:cNvPr>
@@ -3490,8 +3326,8 @@
         </p:blipFill>
         <p:spPr>
           <a:xfrm>
-            <a:off x="41834" y="699347"/>
-            <a:ext cx="9085339" cy="4367107"/>
+            <a:off x="1606549" y="699347"/>
+            <a:ext cx="5791894" cy="4430606"/>
           </a:xfrm>
           <a:prstGeom prst="rect">
             <a:avLst/>
@@ -3645,8 +3481,8 @@
         </p:blipFill>
         <p:spPr>
           <a:xfrm>
-            <a:off x="1625600" y="616375"/>
-            <a:ext cx="5398179" cy="4501375"/>
+            <a:off x="38101" y="571925"/>
+            <a:ext cx="3994150" cy="4501375"/>
           </a:xfrm>
           <a:prstGeom prst="rect">
             <a:avLst/>

</xml_diff>